<commit_message>
Evolução do gerente de projetos na geração de sprint report (gráfico de cobertura).
</commit_message>
<xml_diff>
--- a/artefatos/gerente_de_projetos/report_templates/template_sprint_review_interno.pptx
+++ b/artefatos/gerente_de_projetos/report_templates/template_sprint_review_interno.pptx
@@ -12,11 +12,10 @@
     <p:sldId id="267" r:id="rId6"/>
     <p:sldId id="259" r:id="rId7"/>
     <p:sldId id="260" r:id="rId8"/>
-    <p:sldId id="261" r:id="rId9"/>
-    <p:sldId id="262" r:id="rId10"/>
-    <p:sldId id="263" r:id="rId11"/>
-    <p:sldId id="264" r:id="rId12"/>
-    <p:sldId id="265" r:id="rId13"/>
+    <p:sldId id="262" r:id="rId9"/>
+    <p:sldId id="263" r:id="rId10"/>
+    <p:sldId id="264" r:id="rId11"/>
+    <p:sldId id="265" r:id="rId12"/>
   </p:sldIdLst>
   <p:sldSz cx="9144000" cy="6858000" type="screen4x3"/>
   <p:notesSz cx="7559675" cy="10691813"/>
@@ -8581,229 +8580,6 @@
       </p:grpSpPr>
       <p:sp>
         <p:nvSpPr>
-          <p:cNvPr id="87" name="PlaceHolder 1"/>
-          <p:cNvSpPr>
-            <a:spLocks noGrp="1"/>
-          </p:cNvSpPr>
-          <p:nvPr>
-            <p:ph type="subTitle"/>
-          </p:nvPr>
-        </p:nvSpPr>
-        <p:spPr>
-          <a:xfrm>
-            <a:off x="799919" y="1828081"/>
-            <a:ext cx="7857383" cy="4690706"/>
-          </a:xfrm>
-          <a:prstGeom prst="rect">
-            <a:avLst/>
-          </a:prstGeom>
-          <a:noFill/>
-          <a:ln w="0">
-            <a:noFill/>
-          </a:ln>
-        </p:spPr>
-        <p:txBody>
-          <a:bodyPr lIns="91440" tIns="45720" rIns="91440" bIns="45720" anchor="t">
-            <a:noAutofit/>
-          </a:bodyPr>
-          <a:lstStyle/>
-          <a:p>
-            <a:pPr marL="216000" indent="-216000" algn="l" defTabSz="457200">
-              <a:lnSpc>
-                <a:spcPct val="100000"/>
-              </a:lnSpc>
-              <a:spcBef>
-                <a:spcPts val="1191"/>
-              </a:spcBef>
-              <a:spcAft>
-                <a:spcPts val="992"/>
-              </a:spcAft>
-              <a:buClr>
-                <a:srgbClr val="000000"/>
-              </a:buClr>
-              <a:buSzPct val="45000"/>
-              <a:buFont typeface="Wingdings" charset="2"/>
-              <a:buChar char=""/>
-              <a:tabLst>
-                <a:tab pos="0" algn="l"/>
-              </a:tabLst>
-            </a:pPr>
-            <a:r>
-              <a:rPr lang="pt-BR" sz="2000" b="0" u="none" strike="noStrike" dirty="0">
-                <a:solidFill>
-                  <a:schemeClr val="tx1"/>
-                </a:solidFill>
-                <a:effectLst/>
-                <a:uFillTx/>
-                <a:latin typeface="Calibri"/>
-                <a:ea typeface="Microsoft YaHei"/>
-              </a:rPr>
-              <a:t>{{</a:t>
-            </a:r>
-            <a:r>
-              <a:rPr lang="pt-BR" sz="2400" b="0" u="none" strike="noStrike" dirty="0">
-                <a:solidFill>
-                  <a:schemeClr val="tx1"/>
-                </a:solidFill>
-                <a:effectLst/>
-                <a:uFillTx/>
-                <a:latin typeface="Calibri"/>
-                <a:ea typeface="Microsoft YaHei"/>
-              </a:rPr>
-              <a:t>proximasprint:6</a:t>
-            </a:r>
-            <a:r>
-              <a:rPr lang="pt-BR" sz="2000" b="0" u="none" strike="noStrike" dirty="0">
-                <a:solidFill>
-                  <a:schemeClr val="tx1"/>
-                </a:solidFill>
-                <a:effectLst/>
-                <a:uFillTx/>
-                <a:latin typeface="Calibri"/>
-                <a:ea typeface="Microsoft YaHei"/>
-              </a:rPr>
-              <a:t>}}</a:t>
-            </a:r>
-            <a:endParaRPr lang="pt-BR" sz="2000" b="0" u="none" strike="noStrike" dirty="0">
-              <a:solidFill>
-                <a:schemeClr val="tx1"/>
-              </a:solidFill>
-              <a:effectLst/>
-              <a:uFillTx/>
-              <a:latin typeface="Arial"/>
-            </a:endParaRPr>
-          </a:p>
-        </p:txBody>
-      </p:sp>
-      <p:pic>
-        <p:nvPicPr>
-          <p:cNvPr id="88" name="Imagem 87"/>
-          <p:cNvPicPr/>
-          <p:nvPr/>
-        </p:nvPicPr>
-        <p:blipFill>
-          <a:blip r:embed="rId2"/>
-          <a:stretch/>
-        </p:blipFill>
-        <p:spPr>
-          <a:xfrm>
-            <a:off x="0" y="-28800"/>
-            <a:ext cx="9142560" cy="1647720"/>
-          </a:xfrm>
-          <a:prstGeom prst="rect">
-            <a:avLst/>
-          </a:prstGeom>
-          <a:noFill/>
-          <a:ln w="0">
-            <a:noFill/>
-          </a:ln>
-        </p:spPr>
-      </p:pic>
-      <p:sp>
-        <p:nvSpPr>
-          <p:cNvPr id="89" name="Title 12"/>
-          <p:cNvSpPr/>
-          <p:nvPr/>
-        </p:nvSpPr>
-        <p:spPr>
-          <a:xfrm>
-            <a:off x="915120" y="180360"/>
-            <a:ext cx="8228160" cy="1141560"/>
-          </a:xfrm>
-          <a:prstGeom prst="rect">
-            <a:avLst/>
-          </a:prstGeom>
-          <a:noFill/>
-          <a:ln w="0">
-            <a:noFill/>
-          </a:ln>
-        </p:spPr>
-        <p:style>
-          <a:lnRef idx="0">
-            <a:scrgbClr r="0" g="0" b="0"/>
-          </a:lnRef>
-          <a:fillRef idx="0">
-            <a:scrgbClr r="0" g="0" b="0"/>
-          </a:fillRef>
-          <a:effectRef idx="0">
-            <a:scrgbClr r="0" g="0" b="0"/>
-          </a:effectRef>
-          <a:fontRef idx="minor"/>
-        </p:style>
-        <p:txBody>
-          <a:bodyPr lIns="90000" tIns="45000" rIns="90000" bIns="45000" anchor="ctr">
-            <a:noAutofit/>
-          </a:bodyPr>
-          <a:lstStyle/>
-          <a:p>
-            <a:pPr algn="ctr" defTabSz="457200">
-              <a:lnSpc>
-                <a:spcPct val="100000"/>
-              </a:lnSpc>
-            </a:pPr>
-            <a:r>
-              <a:rPr lang="en-US" sz="4400" b="0" u="none" strike="noStrike">
-                <a:solidFill>
-                  <a:srgbClr val="EA7500"/>
-                </a:solidFill>
-                <a:effectLst/>
-                <a:uFillTx/>
-                <a:latin typeface="Calibri"/>
-              </a:rPr>
-              <a:t>Planejamento da </a:t>
-            </a:r>
-            <a:br>
-              <a:rPr sz="4400"/>
-            </a:br>
-            <a:r>
-              <a:rPr lang="en-US" sz="4400" b="0" u="none" strike="noStrike">
-                <a:solidFill>
-                  <a:srgbClr val="EA7500"/>
-                </a:solidFill>
-                <a:effectLst/>
-                <a:uFillTx/>
-                <a:latin typeface="Calibri"/>
-              </a:rPr>
-              <a:t>próxima Sprint</a:t>
-            </a:r>
-            <a:endParaRPr lang="pt-BR" sz="4400" b="0" u="none" strike="noStrike">
-              <a:solidFill>
-                <a:srgbClr val="000000"/>
-              </a:solidFill>
-              <a:effectLst/>
-              <a:uFillTx/>
-              <a:latin typeface="Arial"/>
-            </a:endParaRPr>
-          </a:p>
-        </p:txBody>
-      </p:sp>
-    </p:spTree>
-  </p:cSld>
-  <p:clrMapOvr>
-    <a:masterClrMapping/>
-  </p:clrMapOvr>
-</p:sld>
-</file>
-
-<file path=ppt/slides/slide11.xml><?xml version="1.0" encoding="utf-8"?>
-<p:sld xmlns:a="http://schemas.openxmlformats.org/drawingml/2006/main" xmlns:r="http://schemas.openxmlformats.org/officeDocument/2006/relationships" xmlns:p="http://schemas.openxmlformats.org/presentationml/2006/main">
-  <p:cSld>
-    <p:spTree>
-      <p:nvGrpSpPr>
-        <p:cNvPr id="1" name=""/>
-        <p:cNvGrpSpPr/>
-        <p:nvPr/>
-      </p:nvGrpSpPr>
-      <p:grpSpPr>
-        <a:xfrm>
-          <a:off x="0" y="0"/>
-          <a:ext cx="0" cy="0"/>
-          <a:chOff x="0" y="0"/>
-          <a:chExt cx="0" cy="0"/>
-        </a:xfrm>
-      </p:grpSpPr>
-      <p:sp>
-        <p:nvSpPr>
           <p:cNvPr id="90" name="PlaceHolder 1"/>
           <p:cNvSpPr>
             <a:spLocks noGrp="1"/>
@@ -9045,7 +8821,7 @@
 </p:sld>
 </file>
 
-<file path=ppt/slides/slide12.xml><?xml version="1.0" encoding="utf-8"?>
+<file path=ppt/slides/slide11.xml><?xml version="1.0" encoding="utf-8"?>
 <p:sld xmlns:a="http://schemas.openxmlformats.org/drawingml/2006/main" xmlns:r="http://schemas.openxmlformats.org/officeDocument/2006/relationships" xmlns:p="http://schemas.openxmlformats.org/presentationml/2006/main">
   <p:cSld>
     <p:spTree>
@@ -10095,8 +9871,8 @@
         </p:nvSpPr>
         <p:spPr>
           <a:xfrm>
-            <a:off x="457919" y="1827720"/>
-            <a:ext cx="8685361" cy="4850280"/>
+            <a:off x="457919" y="1618920"/>
+            <a:ext cx="8685361" cy="5059080"/>
           </a:xfrm>
           <a:prstGeom prst="rect">
             <a:avLst/>
@@ -10174,7 +9950,7 @@
               </a:tabLst>
             </a:pPr>
             <a:r>
-              <a:rPr lang="en-US" sz="2500" b="1" dirty="0">
+              <a:rPr lang="en-US" sz="2400" b="1" dirty="0">
                 <a:solidFill>
                   <a:schemeClr val="dk1"/>
                 </a:solidFill>
@@ -10184,7 +9960,7 @@
               <a:t>Anterior à esse sprint</a:t>
             </a:r>
             <a:r>
-              <a:rPr lang="en-US" sz="2500" dirty="0">
+              <a:rPr lang="en-US" sz="2400" dirty="0">
                 <a:solidFill>
                   <a:schemeClr val="dk1"/>
                 </a:solidFill>
@@ -10194,17 +9970,17 @@
               <a:t>: {{</a:t>
             </a:r>
             <a:r>
-              <a:rPr lang="en-US" sz="2500" dirty="0" err="1">
+              <a:rPr lang="en-US" sz="2400" dirty="0" err="1">
                 <a:solidFill>
                   <a:schemeClr val="dk1"/>
                 </a:solidFill>
                 <a:latin typeface="Calibri"/>
                 <a:ea typeface="Microsoft YaHei"/>
               </a:rPr>
-              <a:t>cobertura_sprint.media_projeto.antes</a:t>
-            </a:r>
-            <a:r>
-              <a:rPr lang="en-US" sz="2500" dirty="0">
+              <a:t>cobertura_sprint.cobertura_ponderada.antes</a:t>
+            </a:r>
+            <a:r>
+              <a:rPr lang="en-US" sz="2400" dirty="0">
                 <a:solidFill>
                   <a:schemeClr val="dk1"/>
                 </a:solidFill>
@@ -10230,7 +10006,7 @@
               </a:tabLst>
             </a:pPr>
             <a:r>
-              <a:rPr lang="en-US" sz="2500" b="1" dirty="0" err="1">
+              <a:rPr lang="en-US" sz="2400" b="1" dirty="0" err="1">
                 <a:solidFill>
                   <a:schemeClr val="dk1"/>
                 </a:solidFill>
@@ -10240,7 +10016,7 @@
               <a:t>Após</a:t>
             </a:r>
             <a:r>
-              <a:rPr lang="en-US" sz="2500" b="1" dirty="0">
+              <a:rPr lang="en-US" sz="2400" b="1" dirty="0">
                 <a:solidFill>
                   <a:schemeClr val="dk1"/>
                 </a:solidFill>
@@ -10250,7 +10026,7 @@
               <a:t> esse sprint</a:t>
             </a:r>
             <a:r>
-              <a:rPr lang="en-US" sz="2500" dirty="0">
+              <a:rPr lang="en-US" sz="2400" dirty="0">
                 <a:solidFill>
                   <a:schemeClr val="dk1"/>
                 </a:solidFill>
@@ -10260,17 +10036,17 @@
               <a:t>: {{</a:t>
             </a:r>
             <a:r>
-              <a:rPr lang="en-US" sz="2500" dirty="0" err="1">
+              <a:rPr lang="en-US" sz="2400" dirty="0" err="1">
                 <a:solidFill>
                   <a:schemeClr val="dk1"/>
                 </a:solidFill>
                 <a:latin typeface="Calibri"/>
                 <a:ea typeface="Microsoft YaHei"/>
               </a:rPr>
-              <a:t>cobertura_sprint.media_projeto.depois</a:t>
-            </a:r>
-            <a:r>
-              <a:rPr lang="en-US" sz="2500" dirty="0">
+              <a:t>cobertura_sprint.cobertura_ponderada.depois</a:t>
+            </a:r>
+            <a:r>
+              <a:rPr lang="en-US" sz="2400" dirty="0">
                 <a:solidFill>
                   <a:schemeClr val="dk1"/>
                 </a:solidFill>
@@ -10296,7 +10072,7 @@
               </a:tabLst>
             </a:pPr>
             <a:r>
-              <a:rPr lang="en-US" sz="2500" b="1" dirty="0" err="1">
+              <a:rPr lang="en-US" sz="2400" b="1" dirty="0" err="1">
                 <a:solidFill>
                   <a:schemeClr val="dk1"/>
                 </a:solidFill>
@@ -10306,7 +10082,7 @@
               <a:t>Diferença</a:t>
             </a:r>
             <a:r>
-              <a:rPr lang="en-US" sz="2500" dirty="0">
+              <a:rPr lang="en-US" sz="2400" dirty="0">
                 <a:solidFill>
                   <a:schemeClr val="dk1"/>
                 </a:solidFill>
@@ -10316,17 +10092,47 @@
               <a:t>: {{</a:t>
             </a:r>
             <a:r>
-              <a:rPr lang="en-US" sz="2500" dirty="0" err="1">
+              <a:rPr lang="en-US" sz="2400" dirty="0" err="1">
                 <a:solidFill>
                   <a:schemeClr val="dk1"/>
                 </a:solidFill>
                 <a:latin typeface="Calibri"/>
                 <a:ea typeface="Microsoft YaHei"/>
               </a:rPr>
-              <a:t>cobertura_sprint.media_projeto.delta_pp</a:t>
-            </a:r>
-            <a:r>
-              <a:rPr lang="en-US" sz="2500" dirty="0">
+              <a:t>cobertura_</a:t>
+            </a:r>
+            <a:r>
+              <a:rPr lang="en-US" sz="2400" err="1">
+                <a:solidFill>
+                  <a:schemeClr val="dk1"/>
+                </a:solidFill>
+                <a:latin typeface="Calibri"/>
+                <a:ea typeface="Microsoft YaHei"/>
+              </a:rPr>
+              <a:t>sprint</a:t>
+            </a:r>
+            <a:r>
+              <a:rPr lang="en-US" sz="2400">
+                <a:solidFill>
+                  <a:schemeClr val="dk1"/>
+                </a:solidFill>
+                <a:latin typeface="Calibri"/>
+                <a:ea typeface="Microsoft YaHei"/>
+              </a:rPr>
+              <a:t>.cobertura</a:t>
+            </a:r>
+            <a:r>
+              <a:rPr lang="en-US" sz="2400" dirty="0" err="1">
+                <a:solidFill>
+                  <a:schemeClr val="dk1"/>
+                </a:solidFill>
+                <a:latin typeface="Calibri"/>
+                <a:ea typeface="Microsoft YaHei"/>
+              </a:rPr>
+              <a:t>_ponderada.delta_pp</a:t>
+            </a:r>
+            <a:r>
+              <a:rPr lang="en-US" sz="2400" dirty="0">
                 <a:solidFill>
                   <a:schemeClr val="dk1"/>
                 </a:solidFill>
@@ -10413,7 +10219,7 @@
               </a:tabLst>
             </a:pPr>
             <a:r>
-              <a:rPr lang="en-US" sz="2500" b="1" dirty="0">
+              <a:rPr lang="en-US" sz="2400" b="1" dirty="0">
                 <a:solidFill>
                   <a:schemeClr val="dk1"/>
                 </a:solidFill>
@@ -10423,7 +10229,7 @@
               <a:t>Total de </a:t>
             </a:r>
             <a:r>
-              <a:rPr lang="en-US" sz="2500" b="1" dirty="0" err="1">
+              <a:rPr lang="en-US" sz="2400" b="1" dirty="0" err="1">
                 <a:solidFill>
                   <a:schemeClr val="dk1"/>
                 </a:solidFill>
@@ -10433,7 +10239,7 @@
               <a:t>requisitos</a:t>
             </a:r>
             <a:r>
-              <a:rPr lang="en-US" sz="2500" b="1" dirty="0">
+              <a:rPr lang="en-US" sz="2400" b="1" dirty="0">
                 <a:solidFill>
                   <a:schemeClr val="dk1"/>
                 </a:solidFill>
@@ -10443,7 +10249,7 @@
               <a:t> </a:t>
             </a:r>
             <a:r>
-              <a:rPr lang="en-US" sz="2500" b="1" dirty="0" err="1">
+              <a:rPr lang="en-US" sz="2400" b="1" dirty="0" err="1">
                 <a:solidFill>
                   <a:schemeClr val="dk1"/>
                 </a:solidFill>
@@ -10453,7 +10259,7 @@
               <a:t>avançados</a:t>
             </a:r>
             <a:r>
-              <a:rPr lang="en-US" sz="2500" dirty="0">
+              <a:rPr lang="en-US" sz="2400" dirty="0">
                 <a:solidFill>
                   <a:schemeClr val="dk1"/>
                 </a:solidFill>
@@ -10463,7 +10269,7 @@
               <a:t>: {{</a:t>
             </a:r>
             <a:r>
-              <a:rPr lang="en-US" sz="2500" dirty="0" err="1">
+              <a:rPr lang="en-US" sz="2400" dirty="0" err="1">
                 <a:solidFill>
                   <a:schemeClr val="dk1"/>
                 </a:solidFill>
@@ -10473,7 +10279,7 @@
               <a:t>cobertura_sprint.reqs_avancados</a:t>
             </a:r>
             <a:r>
-              <a:rPr lang="en-US" sz="2500" dirty="0">
+              <a:rPr lang="en-US" sz="2400" dirty="0">
                 <a:solidFill>
                   <a:schemeClr val="dk1"/>
                 </a:solidFill>
@@ -10499,7 +10305,7 @@
               </a:tabLst>
             </a:pPr>
             <a:r>
-              <a:rPr lang="en-US" sz="2500" b="1" dirty="0">
+              <a:rPr lang="en-US" sz="2400" b="1" dirty="0">
                 <a:solidFill>
                   <a:schemeClr val="dk1"/>
                 </a:solidFill>
@@ -10509,7 +10315,7 @@
               <a:t>Total de </a:t>
             </a:r>
             <a:r>
-              <a:rPr lang="en-US" sz="2500" b="1" dirty="0" err="1">
+              <a:rPr lang="en-US" sz="2400" b="1" dirty="0" err="1">
                 <a:solidFill>
                   <a:schemeClr val="dk1"/>
                 </a:solidFill>
@@ -10519,7 +10325,7 @@
               <a:t>requisitos</a:t>
             </a:r>
             <a:r>
-              <a:rPr lang="en-US" sz="2500" b="1" dirty="0">
+              <a:rPr lang="en-US" sz="2400" b="1" dirty="0">
                 <a:solidFill>
                   <a:schemeClr val="dk1"/>
                 </a:solidFill>
@@ -10529,7 +10335,7 @@
               <a:t> </a:t>
             </a:r>
             <a:r>
-              <a:rPr lang="en-US" sz="2500" b="1" dirty="0" err="1">
+              <a:rPr lang="en-US" sz="2400" b="1" dirty="0" err="1">
                 <a:solidFill>
                   <a:schemeClr val="dk1"/>
                 </a:solidFill>
@@ -10539,7 +10345,7 @@
               <a:t>iniciados</a:t>
             </a:r>
             <a:r>
-              <a:rPr lang="en-US" sz="2500" dirty="0">
+              <a:rPr lang="en-US" sz="2400" dirty="0">
                 <a:solidFill>
                   <a:schemeClr val="dk1"/>
                 </a:solidFill>
@@ -10549,7 +10355,7 @@
               <a:t>: {{</a:t>
             </a:r>
             <a:r>
-              <a:rPr lang="en-US" sz="2500" dirty="0" err="1">
+              <a:rPr lang="en-US" sz="2400" dirty="0" err="1">
                 <a:solidFill>
                   <a:schemeClr val="dk1"/>
                 </a:solidFill>
@@ -10559,7 +10365,7 @@
               <a:t>cobertura_sprint.reqs_novos_iniciados</a:t>
             </a:r>
             <a:r>
-              <a:rPr lang="en-US" sz="2500" dirty="0">
+              <a:rPr lang="en-US" sz="2400" dirty="0">
                 <a:solidFill>
                   <a:schemeClr val="dk1"/>
                 </a:solidFill>
@@ -10785,157 +10591,10 @@
               </a:buClr>
               <a:buSzPct val="45000"/>
             </a:pPr>
+            <a:r>
+              <a:t>{{GRAFICO:cobertura_ponderada}}</a:t>
+            </a:r>
             <a:endParaRPr dirty="0"/>
-          </a:p>
-          <a:p>
-            <a:pPr algn="l" defTabSz="457200">
-              <a:lnSpc>
-                <a:spcPct val="100000"/>
-              </a:lnSpc>
-              <a:spcBef>
-                <a:spcPts val="641"/>
-              </a:spcBef>
-              <a:buClr>
-                <a:srgbClr val="000000"/>
-              </a:buClr>
-              <a:buSzPct val="45000"/>
-              <a:tabLst>
-                <a:tab pos="0" algn="l"/>
-              </a:tabLst>
-            </a:pPr>
-            <a:r>
-              <a:rPr lang="en-US" sz="2600" b="1" dirty="0" err="1">
-                <a:solidFill>
-                  <a:schemeClr val="tx2"/>
-                </a:solidFill>
-              </a:rPr>
-              <a:t>Evolução</a:t>
-            </a:r>
-            <a:r>
-              <a:rPr lang="en-US" sz="2600" b="1" dirty="0">
-                <a:solidFill>
-                  <a:schemeClr val="tx2"/>
-                </a:solidFill>
-              </a:rPr>
-              <a:t> de </a:t>
-            </a:r>
-            <a:r>
-              <a:rPr lang="en-US" sz="2600" b="1" dirty="0" err="1">
-                <a:solidFill>
-                  <a:schemeClr val="tx2"/>
-                </a:solidFill>
-              </a:rPr>
-              <a:t>desenvolvimento</a:t>
-            </a:r>
-            <a:r>
-              <a:rPr lang="en-US" sz="2600" b="1" dirty="0">
-                <a:solidFill>
-                  <a:schemeClr val="tx2"/>
-                </a:solidFill>
-              </a:rPr>
-              <a:t> </a:t>
-            </a:r>
-            <a:r>
-              <a:rPr lang="en-US" sz="2600" b="1" dirty="0" err="1">
-                <a:solidFill>
-                  <a:schemeClr val="tx2"/>
-                </a:solidFill>
-              </a:rPr>
-              <a:t>por</a:t>
-            </a:r>
-            <a:r>
-              <a:rPr lang="en-US" sz="2600" b="1" dirty="0">
-                <a:solidFill>
-                  <a:schemeClr val="tx2"/>
-                </a:solidFill>
-              </a:rPr>
-              <a:t> </a:t>
-            </a:r>
-            <a:r>
-              <a:rPr lang="en-US" sz="2600" b="1" dirty="0" err="1">
-                <a:solidFill>
-                  <a:schemeClr val="tx2"/>
-                </a:solidFill>
-              </a:rPr>
-              <a:t>requisito</a:t>
-            </a:r>
-            <a:r>
-              <a:rPr lang="en-US" sz="2600" b="1" dirty="0">
-                <a:solidFill>
-                  <a:schemeClr val="tx2"/>
-                </a:solidFill>
-              </a:rPr>
-              <a:t>:</a:t>
-            </a:r>
-          </a:p>
-          <a:p>
-            <a:pPr marL="864000" lvl="1" indent="-324000" algn="l" defTabSz="457200">
-              <a:spcBef>
-                <a:spcPts val="561"/>
-              </a:spcBef>
-              <a:buClr>
-                <a:srgbClr val="000000"/>
-              </a:buClr>
-              <a:buSzPct val="45000"/>
-              <a:buFont typeface="Wingdings" charset="2"/>
-              <a:buChar char=""/>
-              <a:tabLst>
-                <a:tab pos="0" algn="l"/>
-              </a:tabLst>
-            </a:pPr>
-            <a:r>
-              <a:rPr lang="en-US" sz="2600" dirty="0">
-                <a:solidFill>
-                  <a:schemeClr val="dk1"/>
-                </a:solidFill>
-                <a:latin typeface="Calibri"/>
-                <a:ea typeface="Microsoft YaHei"/>
-              </a:rPr>
-              <a:t>{{</a:t>
-            </a:r>
-            <a:r>
-              <a:rPr lang="en-US" sz="2600" dirty="0" err="1">
-                <a:solidFill>
-                  <a:schemeClr val="dk1"/>
-                </a:solidFill>
-                <a:latin typeface="Calibri"/>
-                <a:ea typeface="Microsoft YaHei"/>
-              </a:rPr>
-              <a:t>cobertura_sprint.por_req</a:t>
-            </a:r>
-            <a:r>
-              <a:rPr lang="en-US" sz="2600" dirty="0">
-                <a:solidFill>
-                  <a:schemeClr val="dk1"/>
-                </a:solidFill>
-                <a:latin typeface="Calibri"/>
-                <a:ea typeface="Microsoft YaHei"/>
-              </a:rPr>
-              <a:t>}}</a:t>
-            </a:r>
-          </a:p>
-          <a:p>
-            <a:pPr marL="864000" lvl="1" indent="-324000" algn="l" defTabSz="457200">
-              <a:spcBef>
-                <a:spcPts val="561"/>
-              </a:spcBef>
-              <a:buClr>
-                <a:srgbClr val="000000"/>
-              </a:buClr>
-              <a:buSzPct val="45000"/>
-              <a:buFont typeface="Wingdings" charset="2"/>
-              <a:buChar char=""/>
-              <a:tabLst>
-                <a:tab pos="0" algn="l"/>
-              </a:tabLst>
-            </a:pPr>
-            <a:endParaRPr lang="en-US" sz="2600" dirty="0">
-              <a:solidFill>
-                <a:schemeClr val="dk1"/>
-              </a:solidFill>
-              <a:latin typeface="Calibri"/>
-              <a:ea typeface="Microsoft YaHei"/>
-            </a:endParaRPr>
           </a:p>
         </p:txBody>
       </p:sp>
@@ -11066,6 +10725,17 @@
               </a:lnSpc>
             </a:pPr>
             <a:r>
+              <a:rPr lang="en-US" sz="4400" b="0" u="none" strike="noStrike" dirty="0" err="1">
+                <a:solidFill>
+                  <a:srgbClr val="EA7500"/>
+                </a:solidFill>
+                <a:effectLst/>
+                <a:uFillTx/>
+                <a:latin typeface="Calibri"/>
+              </a:rPr>
+              <a:t>por</a:t>
+            </a:r>
+            <a:r>
               <a:rPr lang="en-US" sz="4400" b="0" u="none" strike="noStrike" dirty="0">
                 <a:solidFill>
                   <a:srgbClr val="EA7500"/>
@@ -11074,7 +10744,18 @@
                 <a:uFillTx/>
                 <a:latin typeface="Calibri"/>
               </a:rPr>
-              <a:t> da Sprint</a:t>
+              <a:t> </a:t>
+            </a:r>
+            <a:r>
+              <a:rPr lang="en-US" sz="4400" b="0" u="none" strike="noStrike" dirty="0" err="1">
+                <a:solidFill>
+                  <a:srgbClr val="EA7500"/>
+                </a:solidFill>
+                <a:effectLst/>
+                <a:uFillTx/>
+                <a:latin typeface="Calibri"/>
+              </a:rPr>
+              <a:t>requisito</a:t>
             </a:r>
             <a:endParaRPr lang="pt-BR" sz="4400" b="0" u="none" strike="noStrike" dirty="0">
               <a:solidFill>
@@ -12374,225 +12055,6 @@
       </p:grpSpPr>
       <p:sp>
         <p:nvSpPr>
-          <p:cNvPr id="80" name="PlaceHolder 1"/>
-          <p:cNvSpPr>
-            <a:spLocks noGrp="1"/>
-          </p:cNvSpPr>
-          <p:nvPr>
-            <p:ph/>
-          </p:nvPr>
-        </p:nvSpPr>
-        <p:spPr>
-          <a:xfrm>
-            <a:off x="457920" y="1321560"/>
-            <a:ext cx="8228160" cy="5356440"/>
-          </a:xfrm>
-          <a:prstGeom prst="rect">
-            <a:avLst/>
-          </a:prstGeom>
-          <a:noFill/>
-          <a:ln w="0">
-            <a:noFill/>
-          </a:ln>
-        </p:spPr>
-        <p:txBody>
-          <a:bodyPr lIns="91440" tIns="45720" rIns="91440" bIns="45720" anchor="t">
-            <a:noAutofit/>
-          </a:bodyPr>
-          <a:lstStyle/>
-          <a:p>
-            <a:pPr indent="0" algn="l" defTabSz="457200">
-              <a:lnSpc>
-                <a:spcPct val="100000"/>
-              </a:lnSpc>
-              <a:spcBef>
-                <a:spcPts val="641"/>
-              </a:spcBef>
-              <a:buNone/>
-              <a:tabLst>
-                <a:tab pos="0" algn="l"/>
-              </a:tabLst>
-            </a:pPr>
-            <a:endParaRPr lang="en-US" sz="3200" b="0" u="none" strike="noStrike" dirty="0">
-              <a:solidFill>
-                <a:schemeClr val="dk1"/>
-              </a:solidFill>
-              <a:effectLst/>
-              <a:uFillTx/>
-              <a:latin typeface="Calibri"/>
-            </a:endParaRPr>
-          </a:p>
-          <a:p>
-            <a:pPr marL="343080" indent="-343080" algn="l" defTabSz="457200">
-              <a:lnSpc>
-                <a:spcPct val="100000"/>
-              </a:lnSpc>
-              <a:spcBef>
-                <a:spcPts val="1191"/>
-              </a:spcBef>
-              <a:spcAft>
-                <a:spcPts val="992"/>
-              </a:spcAft>
-              <a:buClr>
-                <a:srgbClr val="000000"/>
-              </a:buClr>
-              <a:buFont typeface="Arial"/>
-              <a:buChar char="•"/>
-              <a:tabLst>
-                <a:tab pos="0" algn="l"/>
-              </a:tabLst>
-            </a:pPr>
-            <a:r>
-              <a:rPr lang="en-US" sz="2000" b="0" u="none" strike="noStrike" dirty="0">
-                <a:solidFill>
-                  <a:schemeClr val="dk1"/>
-                </a:solidFill>
-                <a:effectLst/>
-                <a:uFillTx/>
-                <a:latin typeface="Calibri"/>
-              </a:rPr>
-              <a:t>{{insights:3}}</a:t>
-            </a:r>
-          </a:p>
-        </p:txBody>
-      </p:sp>
-      <p:pic>
-        <p:nvPicPr>
-          <p:cNvPr id="81" name="Imagem 80"/>
-          <p:cNvPicPr/>
-          <p:nvPr/>
-        </p:nvPicPr>
-        <p:blipFill>
-          <a:blip r:embed="rId2"/>
-          <a:stretch/>
-        </p:blipFill>
-        <p:spPr>
-          <a:xfrm>
-            <a:off x="720" y="-28800"/>
-            <a:ext cx="9142560" cy="1647720"/>
-          </a:xfrm>
-          <a:prstGeom prst="rect">
-            <a:avLst/>
-          </a:prstGeom>
-          <a:noFill/>
-          <a:ln w="0">
-            <a:noFill/>
-          </a:ln>
-        </p:spPr>
-      </p:pic>
-      <p:sp>
-        <p:nvSpPr>
-          <p:cNvPr id="82" name="Title 6"/>
-          <p:cNvSpPr/>
-          <p:nvPr/>
-        </p:nvSpPr>
-        <p:spPr>
-          <a:xfrm>
-            <a:off x="915480" y="180000"/>
-            <a:ext cx="8228160" cy="1141560"/>
-          </a:xfrm>
-          <a:prstGeom prst="rect">
-            <a:avLst/>
-          </a:prstGeom>
-          <a:noFill/>
-          <a:ln w="0">
-            <a:noFill/>
-          </a:ln>
-        </p:spPr>
-        <p:style>
-          <a:lnRef idx="0">
-            <a:scrgbClr r="0" g="0" b="0"/>
-          </a:lnRef>
-          <a:fillRef idx="0">
-            <a:scrgbClr r="0" g="0" b="0"/>
-          </a:fillRef>
-          <a:effectRef idx="0">
-            <a:scrgbClr r="0" g="0" b="0"/>
-          </a:effectRef>
-          <a:fontRef idx="minor"/>
-        </p:style>
-        <p:txBody>
-          <a:bodyPr lIns="90000" tIns="45000" rIns="90000" bIns="45000" anchor="ctr">
-            <a:noAutofit/>
-          </a:bodyPr>
-          <a:lstStyle/>
-          <a:p>
-            <a:pPr algn="ctr" defTabSz="457200">
-              <a:lnSpc>
-                <a:spcPct val="100000"/>
-              </a:lnSpc>
-            </a:pPr>
-            <a:r>
-              <a:rPr lang="en-US" sz="4400" b="0" u="none" strike="noStrike" dirty="0" err="1">
-                <a:solidFill>
-                  <a:srgbClr val="EA7500"/>
-                </a:solidFill>
-                <a:effectLst/>
-                <a:uFillTx/>
-                <a:latin typeface="Calibri"/>
-              </a:rPr>
-              <a:t>Informações</a:t>
-            </a:r>
-            <a:r>
-              <a:rPr lang="en-US" sz="4400" b="0" u="none" strike="noStrike" dirty="0">
-                <a:solidFill>
-                  <a:srgbClr val="EA7500"/>
-                </a:solidFill>
-                <a:effectLst/>
-                <a:uFillTx/>
-                <a:latin typeface="Calibri"/>
-              </a:rPr>
-              <a:t> </a:t>
-            </a:r>
-            <a:r>
-              <a:rPr lang="en-US" sz="4400" b="0" u="none" strike="noStrike" dirty="0" err="1">
-                <a:solidFill>
-                  <a:srgbClr val="EA7500"/>
-                </a:solidFill>
-                <a:effectLst/>
-                <a:uFillTx/>
-                <a:latin typeface="Calibri"/>
-              </a:rPr>
-              <a:t>adicionais</a:t>
-            </a:r>
-            <a:endParaRPr lang="pt-BR" sz="4400" b="0" u="none" strike="noStrike" dirty="0">
-              <a:solidFill>
-                <a:srgbClr val="000000"/>
-              </a:solidFill>
-              <a:effectLst/>
-              <a:uFillTx/>
-              <a:latin typeface="Arial"/>
-            </a:endParaRPr>
-          </a:p>
-        </p:txBody>
-      </p:sp>
-    </p:spTree>
-  </p:cSld>
-  <p:clrMapOvr>
-    <a:masterClrMapping/>
-  </p:clrMapOvr>
-</p:sld>
-</file>
-
-<file path=ppt/slides/slide9.xml><?xml version="1.0" encoding="utf-8"?>
-<p:sld xmlns:a="http://schemas.openxmlformats.org/drawingml/2006/main" xmlns:r="http://schemas.openxmlformats.org/officeDocument/2006/relationships" xmlns:p="http://schemas.openxmlformats.org/presentationml/2006/main">
-  <p:cSld>
-    <p:spTree>
-      <p:nvGrpSpPr>
-        <p:cNvPr id="1" name=""/>
-        <p:cNvGrpSpPr/>
-        <p:nvPr/>
-      </p:nvGrpSpPr>
-      <p:grpSpPr>
-        <a:xfrm>
-          <a:off x="0" y="0"/>
-          <a:ext cx="0" cy="0"/>
-          <a:chOff x="0" y="0"/>
-          <a:chExt cx="0" cy="0"/>
-        </a:xfrm>
-      </p:grpSpPr>
-      <p:sp>
-        <p:nvSpPr>
           <p:cNvPr id="83" name="PlaceHolder 1"/>
           <p:cNvSpPr>
             <a:spLocks noGrp="1"/>
@@ -12803,6 +12265,229 @@
       <p:sp>
         <p:nvSpPr>
           <p:cNvPr id="86" name="Title 1"/>
+          <p:cNvSpPr/>
+          <p:nvPr/>
+        </p:nvSpPr>
+        <p:spPr>
+          <a:xfrm>
+            <a:off x="915120" y="180360"/>
+            <a:ext cx="8228160" cy="1141560"/>
+          </a:xfrm>
+          <a:prstGeom prst="rect">
+            <a:avLst/>
+          </a:prstGeom>
+          <a:noFill/>
+          <a:ln w="0">
+            <a:noFill/>
+          </a:ln>
+        </p:spPr>
+        <p:style>
+          <a:lnRef idx="0">
+            <a:scrgbClr r="0" g="0" b="0"/>
+          </a:lnRef>
+          <a:fillRef idx="0">
+            <a:scrgbClr r="0" g="0" b="0"/>
+          </a:fillRef>
+          <a:effectRef idx="0">
+            <a:scrgbClr r="0" g="0" b="0"/>
+          </a:effectRef>
+          <a:fontRef idx="minor"/>
+        </p:style>
+        <p:txBody>
+          <a:bodyPr lIns="90000" tIns="45000" rIns="90000" bIns="45000" anchor="ctr">
+            <a:noAutofit/>
+          </a:bodyPr>
+          <a:lstStyle/>
+          <a:p>
+            <a:pPr algn="ctr" defTabSz="457200">
+              <a:lnSpc>
+                <a:spcPct val="100000"/>
+              </a:lnSpc>
+            </a:pPr>
+            <a:r>
+              <a:rPr lang="en-US" sz="4400" b="0" u="none" strike="noStrike">
+                <a:solidFill>
+                  <a:srgbClr val="EA7500"/>
+                </a:solidFill>
+                <a:effectLst/>
+                <a:uFillTx/>
+                <a:latin typeface="Calibri"/>
+              </a:rPr>
+              <a:t>Planejamento da </a:t>
+            </a:r>
+            <a:br>
+              <a:rPr sz="4400"/>
+            </a:br>
+            <a:r>
+              <a:rPr lang="en-US" sz="4400" b="0" u="none" strike="noStrike">
+                <a:solidFill>
+                  <a:srgbClr val="EA7500"/>
+                </a:solidFill>
+                <a:effectLst/>
+                <a:uFillTx/>
+                <a:latin typeface="Calibri"/>
+              </a:rPr>
+              <a:t>próxima Sprint</a:t>
+            </a:r>
+            <a:endParaRPr lang="pt-BR" sz="4400" b="0" u="none" strike="noStrike">
+              <a:solidFill>
+                <a:srgbClr val="000000"/>
+              </a:solidFill>
+              <a:effectLst/>
+              <a:uFillTx/>
+              <a:latin typeface="Arial"/>
+            </a:endParaRPr>
+          </a:p>
+        </p:txBody>
+      </p:sp>
+    </p:spTree>
+  </p:cSld>
+  <p:clrMapOvr>
+    <a:masterClrMapping/>
+  </p:clrMapOvr>
+</p:sld>
+</file>
+
+<file path=ppt/slides/slide9.xml><?xml version="1.0" encoding="utf-8"?>
+<p:sld xmlns:a="http://schemas.openxmlformats.org/drawingml/2006/main" xmlns:r="http://schemas.openxmlformats.org/officeDocument/2006/relationships" xmlns:p="http://schemas.openxmlformats.org/presentationml/2006/main">
+  <p:cSld>
+    <p:spTree>
+      <p:nvGrpSpPr>
+        <p:cNvPr id="1" name=""/>
+        <p:cNvGrpSpPr/>
+        <p:nvPr/>
+      </p:nvGrpSpPr>
+      <p:grpSpPr>
+        <a:xfrm>
+          <a:off x="0" y="0"/>
+          <a:ext cx="0" cy="0"/>
+          <a:chOff x="0" y="0"/>
+          <a:chExt cx="0" cy="0"/>
+        </a:xfrm>
+      </p:grpSpPr>
+      <p:sp>
+        <p:nvSpPr>
+          <p:cNvPr id="87" name="PlaceHolder 1"/>
+          <p:cNvSpPr>
+            <a:spLocks noGrp="1"/>
+          </p:cNvSpPr>
+          <p:nvPr>
+            <p:ph type="subTitle"/>
+          </p:nvPr>
+        </p:nvSpPr>
+        <p:spPr>
+          <a:xfrm>
+            <a:off x="799919" y="1828081"/>
+            <a:ext cx="7857383" cy="4690706"/>
+          </a:xfrm>
+          <a:prstGeom prst="rect">
+            <a:avLst/>
+          </a:prstGeom>
+          <a:noFill/>
+          <a:ln w="0">
+            <a:noFill/>
+          </a:ln>
+        </p:spPr>
+        <p:txBody>
+          <a:bodyPr lIns="91440" tIns="45720" rIns="91440" bIns="45720" anchor="t">
+            <a:noAutofit/>
+          </a:bodyPr>
+          <a:lstStyle/>
+          <a:p>
+            <a:pPr marL="216000" indent="-216000" algn="l" defTabSz="457200">
+              <a:lnSpc>
+                <a:spcPct val="100000"/>
+              </a:lnSpc>
+              <a:spcBef>
+                <a:spcPts val="1191"/>
+              </a:spcBef>
+              <a:spcAft>
+                <a:spcPts val="992"/>
+              </a:spcAft>
+              <a:buClr>
+                <a:srgbClr val="000000"/>
+              </a:buClr>
+              <a:buSzPct val="45000"/>
+              <a:buFont typeface="Wingdings" charset="2"/>
+              <a:buChar char=""/>
+              <a:tabLst>
+                <a:tab pos="0" algn="l"/>
+              </a:tabLst>
+            </a:pPr>
+            <a:r>
+              <a:rPr lang="pt-BR" sz="2000" b="0" u="none" strike="noStrike" dirty="0">
+                <a:solidFill>
+                  <a:schemeClr val="tx1"/>
+                </a:solidFill>
+                <a:effectLst/>
+                <a:uFillTx/>
+                <a:latin typeface="Calibri"/>
+                <a:ea typeface="Microsoft YaHei"/>
+              </a:rPr>
+              <a:t>{{</a:t>
+            </a:r>
+            <a:r>
+              <a:rPr lang="pt-BR" sz="2400" b="0" u="none" strike="noStrike" dirty="0">
+                <a:solidFill>
+                  <a:schemeClr val="tx1"/>
+                </a:solidFill>
+                <a:effectLst/>
+                <a:uFillTx/>
+                <a:latin typeface="Calibri"/>
+                <a:ea typeface="Microsoft YaHei"/>
+              </a:rPr>
+              <a:t>proximasprint:6</a:t>
+            </a:r>
+            <a:r>
+              <a:rPr lang="pt-BR" sz="2000" b="0" u="none" strike="noStrike" dirty="0">
+                <a:solidFill>
+                  <a:schemeClr val="tx1"/>
+                </a:solidFill>
+                <a:effectLst/>
+                <a:uFillTx/>
+                <a:latin typeface="Calibri"/>
+                <a:ea typeface="Microsoft YaHei"/>
+              </a:rPr>
+              <a:t>}}</a:t>
+            </a:r>
+            <a:endParaRPr lang="pt-BR" sz="2000" b="0" u="none" strike="noStrike" dirty="0">
+              <a:solidFill>
+                <a:schemeClr val="tx1"/>
+              </a:solidFill>
+              <a:effectLst/>
+              <a:uFillTx/>
+              <a:latin typeface="Arial"/>
+            </a:endParaRPr>
+          </a:p>
+        </p:txBody>
+      </p:sp>
+      <p:pic>
+        <p:nvPicPr>
+          <p:cNvPr id="88" name="Imagem 87"/>
+          <p:cNvPicPr/>
+          <p:nvPr/>
+        </p:nvPicPr>
+        <p:blipFill>
+          <a:blip r:embed="rId2"/>
+          <a:stretch/>
+        </p:blipFill>
+        <p:spPr>
+          <a:xfrm>
+            <a:off x="0" y="-28800"/>
+            <a:ext cx="9142560" cy="1647720"/>
+          </a:xfrm>
+          <a:prstGeom prst="rect">
+            <a:avLst/>
+          </a:prstGeom>
+          <a:noFill/>
+          <a:ln w="0">
+            <a:noFill/>
+          </a:ln>
+        </p:spPr>
+      </p:pic>
+      <p:sp>
+        <p:nvSpPr>
+          <p:cNvPr id="89" name="Title 12"/>
           <p:cNvSpPr/>
           <p:nvPr/>
         </p:nvSpPr>

</xml_diff>